<commit_message>
Partnership deck: use JiPange's current copy (21 calculators)
Mwangaza carried its own copy of the deck, already out of date (25
calculators against the 26 JiPange then shipped, and now 21 after the
salary tools were merged into the hub). Two copies drift; this one is
now the same file as JiPange's.

Co-Authored-By: Claude Sonnet 5.5 <noreply@anthropic.com>
Claude-Session: https://claude.ai/code/session_01SW7AAhG6987WGY5UWymi4C
</commit_message>
<xml_diff>
--- a/public/partners/jipange-mwangaza-partnership-deck.pptx
+++ b/public/partners/jipange-mwangaza-partnership-deck.pptx
@@ -1019,7 +1019,7 @@
                 <a:latin typeface="QuattrocentoSans"/>
                 <a:ea typeface="QuattrocentoSans"/>
               </a:rPr>
-              <a:t>Kenya's financial planning copilot — 25 calculators, 6 goal planners, a 90-second Pesa Picture.</a:t>
+              <a:t>Kenya's financial planning copilot — 21 calculators, 6 goal planners, a 90-second Pesa Picture.</a:t>
             </a:r>
             <a:endParaRPr lang="en-US" sz="1600" noProof="1"/>
           </a:p>
@@ -1499,7 +1499,7 @@
                 <a:latin typeface="QuattrocentoSans"/>
                 <a:ea typeface="QuattrocentoSans"/>
               </a:rPr>
-              <a:t>Where does my money go? Which vehicle fits my life stage and goal? JiPange answers with 25 calculators and 6 goal planners built on Kenya's actual financial architecture. Its investment-returns and retirement tools surface government bonds — and hand the user directly to Mwangaza to act.</a:t>
+              <a:t>Where does my money go? Which vehicle fits my life stage and goal? JiPange answers with 21 calculators and 6 goal planners built on Kenya's actual financial architecture. Its investment-returns and retirement tools surface government bonds — and hand the user directly to Mwangaza to act.</a:t>
             </a:r>
             <a:endParaRPr lang="en-US" sz="1100" noProof="1"/>
           </a:p>
@@ -6875,7 +6875,7 @@
                 <a:latin typeface="MiSans"/>
                 <a:ea typeface="MiSans"/>
               </a:rPr>
-              <a:t>JiPange: 25 calculators, 6 planners. Mwangaza: 58 bonds, 387 auction records. Both live; mobile money exceeds $300B a year — 5% of GDP.</a:t>
+              <a:t>JiPange: 21 calculators, 6 planners. Mwangaza: 58 bonds, 387 auction records. Both live; mobile money exceeds $300B a year — 5% of GDP.</a:t>
             </a:r>
             <a:endParaRPr lang="en-US" sz="1600" noProof="1"/>
           </a:p>
@@ -8626,7 +8626,7 @@
                 <a:latin typeface="QuattrocentoSans"/>
                 <a:ea typeface="QuattrocentoSans"/>
               </a:rPr>
-              <a:t>Live now — 25 calculators, 6 planners, a 90-second Pesa Picture. Free to explore today.</a:t>
+              <a:t>Live now — 21 calculators, 6 planners, a 90-second Pesa Picture. Free to explore today.</a:t>
             </a:r>
             <a:endParaRPr lang="en-US" sz="1600" noProof="1"/>
           </a:p>
@@ -9132,7 +9132,7 @@
                 <a:latin typeface="QuattrocentoSans"/>
                 <a:ea typeface="QuattrocentoSans"/>
               </a:rPr>
-              <a:t> — 25 Kenya-specific calculators, 6 goal planners, a 90-second Pesa Picture. </a:t>
+              <a:t> — 26 Kenya-specific calculators, 6 goal planners, a 90-second Pesa Picture. </a:t>
             </a:r>
             <a:r>
               <a:rPr lang="en-US" sz="1100" noProof="1" b="1">
@@ -13294,7 +13294,7 @@
                 <a:latin typeface="Oranienbaum"/>
                 <a:ea typeface="Oranienbaum"/>
               </a:rPr>
-              <a:t>25 calculators</a:t>
+              <a:t>21 calculators</a:t>
             </a:r>
             <a:endParaRPr lang="en-US" sz="1600" noProof="1"/>
           </a:p>
@@ -13598,7 +13598,7 @@
                 <a:latin typeface="Oranienbaum"/>
                 <a:ea typeface="Oranienbaum"/>
               </a:rPr>
-              <a:t>25 calculators that speak Kenya's financial language</a:t>
+              <a:t>21 calculators that speak Kenya's financial language</a:t>
             </a:r>
             <a:endParaRPr lang="en-US" sz="3100" noProof="1"/>
           </a:p>

</xml_diff>

<commit_message>
Partnership deck: use JiPange's current copy (21 calculators) (#381)
Mwangaza carried its own copy of the deck, already out of date (25
calculators against the 26 JiPange then shipped, and now 21 after the
salary tools were merged into the hub). Two copies drift; this one is
now the same file as JiPange's.


Claude-Session: https://claude.ai/code/session_01SW7AAhG6987WGY5UWymi4C

Co-authored-by: Claude <noreply@anthropic.com>
</commit_message>
<xml_diff>
--- a/public/partners/jipange-mwangaza-partnership-deck.pptx
+++ b/public/partners/jipange-mwangaza-partnership-deck.pptx
@@ -1019,7 +1019,7 @@
                 <a:latin typeface="QuattrocentoSans"/>
                 <a:ea typeface="QuattrocentoSans"/>
               </a:rPr>
-              <a:t>Kenya's financial planning copilot — 25 calculators, 6 goal planners, a 90-second Pesa Picture.</a:t>
+              <a:t>Kenya's financial planning copilot — 21 calculators, 6 goal planners, a 90-second Pesa Picture.</a:t>
             </a:r>
             <a:endParaRPr lang="en-US" sz="1600" noProof="1"/>
           </a:p>
@@ -1499,7 +1499,7 @@
                 <a:latin typeface="QuattrocentoSans"/>
                 <a:ea typeface="QuattrocentoSans"/>
               </a:rPr>
-              <a:t>Where does my money go? Which vehicle fits my life stage and goal? JiPange answers with 25 calculators and 6 goal planners built on Kenya's actual financial architecture. Its investment-returns and retirement tools surface government bonds — and hand the user directly to Mwangaza to act.</a:t>
+              <a:t>Where does my money go? Which vehicle fits my life stage and goal? JiPange answers with 21 calculators and 6 goal planners built on Kenya's actual financial architecture. Its investment-returns and retirement tools surface government bonds — and hand the user directly to Mwangaza to act.</a:t>
             </a:r>
             <a:endParaRPr lang="en-US" sz="1100" noProof="1"/>
           </a:p>
@@ -6875,7 +6875,7 @@
                 <a:latin typeface="MiSans"/>
                 <a:ea typeface="MiSans"/>
               </a:rPr>
-              <a:t>JiPange: 25 calculators, 6 planners. Mwangaza: 58 bonds, 387 auction records. Both live; mobile money exceeds $300B a year — 5% of GDP.</a:t>
+              <a:t>JiPange: 21 calculators, 6 planners. Mwangaza: 58 bonds, 387 auction records. Both live; mobile money exceeds $300B a year — 5% of GDP.</a:t>
             </a:r>
             <a:endParaRPr lang="en-US" sz="1600" noProof="1"/>
           </a:p>
@@ -8626,7 +8626,7 @@
                 <a:latin typeface="QuattrocentoSans"/>
                 <a:ea typeface="QuattrocentoSans"/>
               </a:rPr>
-              <a:t>Live now — 25 calculators, 6 planners, a 90-second Pesa Picture. Free to explore today.</a:t>
+              <a:t>Live now — 21 calculators, 6 planners, a 90-second Pesa Picture. Free to explore today.</a:t>
             </a:r>
             <a:endParaRPr lang="en-US" sz="1600" noProof="1"/>
           </a:p>
@@ -9132,7 +9132,7 @@
                 <a:latin typeface="QuattrocentoSans"/>
                 <a:ea typeface="QuattrocentoSans"/>
               </a:rPr>
-              <a:t> — 25 Kenya-specific calculators, 6 goal planners, a 90-second Pesa Picture. </a:t>
+              <a:t> — 26 Kenya-specific calculators, 6 goal planners, a 90-second Pesa Picture. </a:t>
             </a:r>
             <a:r>
               <a:rPr lang="en-US" sz="1100" noProof="1" b="1">
@@ -13294,7 +13294,7 @@
                 <a:latin typeface="Oranienbaum"/>
                 <a:ea typeface="Oranienbaum"/>
               </a:rPr>
-              <a:t>25 calculators</a:t>
+              <a:t>21 calculators</a:t>
             </a:r>
             <a:endParaRPr lang="en-US" sz="1600" noProof="1"/>
           </a:p>
@@ -13598,7 +13598,7 @@
                 <a:latin typeface="Oranienbaum"/>
                 <a:ea typeface="Oranienbaum"/>
               </a:rPr>
-              <a:t>25 calculators that speak Kenya's financial language</a:t>
+              <a:t>21 calculators that speak Kenya's financial language</a:t>
             </a:r>
             <a:endParaRPr lang="en-US" sz="3100" noProof="1"/>
           </a:p>

</xml_diff>